<commit_message>
added practicals for Day 4
</commit_message>
<xml_diff>
--- a/slides/Day4/F_statistics.pptx
+++ b/slides/Day4/F_statistics.pptx
@@ -13,6 +13,8 @@
     <p:sldId id="261" r:id="rId8"/>
     <p:sldId id="262" r:id="rId9"/>
     <p:sldId id="263" r:id="rId10"/>
+    <p:sldId id="264" r:id="rId11"/>
+    <p:sldId id="265" r:id="rId12"/>
   </p:sldIdLst>
   <p:sldSz cx="10080625" cy="5670550"/>
   <p:notesSz cx="7559675" cy="10691813"/>
@@ -20,6 +22,172 @@
 </file>
 
 <file path=ppt/slideLayouts/slideLayout1.xml><?xml version="1.0" encoding="utf-8"?>
+<p:sldLayout xmlns:a="http://schemas.openxmlformats.org/drawingml/2006/main" xmlns:p="http://schemas.openxmlformats.org/presentationml/2006/main" xmlns:r="http://schemas.openxmlformats.org/officeDocument/2006/relationships" xmlns:p14="http://schemas.microsoft.com/office/powerpoint/2010/main" xmlns:p15="http://schemas.microsoft.com/office/powerpoint/2012/main" xmlns:mc="http://schemas.openxmlformats.org/markup-compatibility/2006" type="tx" preserve="1">
+  <p:cSld name="Default">
+    <p:spTree>
+      <p:nvGrpSpPr>
+        <p:cNvPr id="1" name=""/>
+        <p:cNvGrpSpPr/>
+        <p:nvPr/>
+      </p:nvGrpSpPr>
+      <p:grpSpPr>
+        <a:xfrm>
+          <a:off x="0" y="0"/>
+          <a:ext cx="0" cy="0"/>
+          <a:chOff x="0" y="0"/>
+          <a:chExt cx="0" cy="0"/>
+        </a:xfrm>
+      </p:grpSpPr>
+      <p:sp>
+        <p:nvSpPr>
+          <p:cNvPr id="5" name="PlaceHolder 1"/>
+          <p:cNvSpPr>
+            <a:spLocks noGrp="1"/>
+          </p:cNvSpPr>
+          <p:nvPr>
+            <p:ph type="title"/>
+          </p:nvPr>
+        </p:nvSpPr>
+        <p:spPr>
+          <a:xfrm>
+            <a:off x="504000" y="226080"/>
+            <a:ext cx="9071280" cy="946080"/>
+          </a:xfrm>
+          <a:prstGeom prst="rect">
+            <a:avLst/>
+          </a:prstGeom>
+          <a:noFill/>
+          <a:ln w="0">
+            <a:noFill/>
+          </a:ln>
+        </p:spPr>
+        <p:txBody>
+          <a:bodyPr lIns="0" rIns="0" tIns="0" bIns="0" anchor="ctr">
+            <a:noAutofit/>
+          </a:bodyPr>
+          <a:p>
+            <a:pPr indent="0" algn="ctr">
+              <a:buNone/>
+            </a:pPr>
+            <a:endParaRPr b="0" lang="en-US" sz="4400" spc="-1" strike="noStrike">
+              <a:solidFill>
+                <a:srgbClr val="000000"/>
+              </a:solidFill>
+              <a:latin typeface="Arial"/>
+            </a:endParaRPr>
+          </a:p>
+        </p:txBody>
+      </p:sp>
+      <p:sp>
+        <p:nvSpPr>
+          <p:cNvPr id="6" name="PlaceHolder 2"/>
+          <p:cNvSpPr>
+            <a:spLocks noGrp="1"/>
+          </p:cNvSpPr>
+          <p:nvPr>
+            <p:ph/>
+          </p:nvPr>
+        </p:nvSpPr>
+        <p:spPr>
+          <a:xfrm>
+            <a:off x="504000" y="1326600"/>
+            <a:ext cx="9072000" cy="3288600"/>
+          </a:xfrm>
+          <a:prstGeom prst="rect">
+            <a:avLst/>
+          </a:prstGeom>
+          <a:noFill/>
+          <a:ln w="0">
+            <a:noFill/>
+          </a:ln>
+        </p:spPr>
+        <p:txBody>
+          <a:bodyPr lIns="0" rIns="0" tIns="0" bIns="0" anchor="t">
+            <a:normAutofit/>
+          </a:bodyPr>
+          <a:p>
+            <a:pPr indent="0">
+              <a:spcBef>
+                <a:spcPts val="1417"/>
+              </a:spcBef>
+              <a:buNone/>
+            </a:pPr>
+            <a:endParaRPr b="0" lang="en-US" sz="3200" spc="-1" strike="noStrike">
+              <a:solidFill>
+                <a:srgbClr val="000000"/>
+              </a:solidFill>
+              <a:latin typeface="Arial"/>
+            </a:endParaRPr>
+          </a:p>
+        </p:txBody>
+      </p:sp>
+      <p:sp>
+        <p:nvSpPr>
+          <p:cNvPr id="4" name="PlaceHolder 3"/>
+          <p:cNvSpPr>
+            <a:spLocks noGrp="1"/>
+          </p:cNvSpPr>
+          <p:nvPr>
+            <p:ph type="ftr" idx="1"/>
+          </p:nvPr>
+        </p:nvSpPr>
+        <p:spPr/>
+        <p:txBody>
+          <a:bodyPr/>
+          <a:p>
+            <a:r>
+              <a:t>Footer</a:t>
+            </a:r>
+          </a:p>
+        </p:txBody>
+      </p:sp>
+      <p:sp>
+        <p:nvSpPr>
+          <p:cNvPr id="5" name="PlaceHolder 4"/>
+          <p:cNvSpPr>
+            <a:spLocks noGrp="1"/>
+          </p:cNvSpPr>
+          <p:nvPr>
+            <p:ph type="sldNum" idx="2"/>
+          </p:nvPr>
+        </p:nvSpPr>
+        <p:spPr/>
+        <p:txBody>
+          <a:bodyPr/>
+          <a:p>
+            <a:fld id="{1E4DD10F-171B-4ED7-9ADD-E041FD34547D}" type="slidenum">
+              <a:t>&lt;#&gt;</a:t>
+            </a:fld>
+          </a:p>
+        </p:txBody>
+      </p:sp>
+      <p:sp>
+        <p:nvSpPr>
+          <p:cNvPr id="6" name="PlaceHolder 5"/>
+          <p:cNvSpPr>
+            <a:spLocks noGrp="1"/>
+          </p:cNvSpPr>
+          <p:nvPr>
+            <p:ph type="dt" idx="3"/>
+          </p:nvPr>
+        </p:nvSpPr>
+        <p:spPr/>
+        <p:txBody>
+          <a:bodyPr/>
+          <a:p>
+            <a:r>
+              <a:rPr lang="en-US"/>
+              <a:t/>
+            </a:r>
+          </a:p>
+        </p:txBody>
+      </p:sp>
+    </p:spTree>
+  </p:cSld>
+</p:sldLayout>
+</file>
+
+<file path=ppt/slideLayouts/slideLayout2.xml><?xml version="1.0" encoding="utf-8"?>
 <p:sldLayout xmlns:a="http://schemas.openxmlformats.org/drawingml/2006/main" xmlns:p="http://schemas.openxmlformats.org/presentationml/2006/main" xmlns:r="http://schemas.openxmlformats.org/officeDocument/2006/relationships" xmlns:p14="http://schemas.microsoft.com/office/powerpoint/2010/main" xmlns:p15="http://schemas.microsoft.com/office/powerpoint/2012/main" xmlns:mc="http://schemas.openxmlformats.org/markup-compatibility/2006" type="title" preserve="1">
   <p:cSld name="Default">
     <p:spTree>
@@ -38,7 +206,7 @@
       </p:grpSpPr>
       <p:sp>
         <p:nvSpPr>
-          <p:cNvPr id="5" name="PlaceHolder 1"/>
+          <p:cNvPr id="7" name="PlaceHolder 1"/>
           <p:cNvSpPr>
             <a:spLocks noGrp="1"/>
           </p:cNvSpPr>
@@ -49,7 +217,7 @@
         <p:spPr>
           <a:xfrm>
             <a:off x="504000" y="226080"/>
-            <a:ext cx="9071640" cy="946440"/>
+            <a:ext cx="9071280" cy="946080"/>
           </a:xfrm>
           <a:prstGeom prst="rect">
             <a:avLst/>
@@ -78,7 +246,7 @@
       </p:sp>
       <p:sp>
         <p:nvSpPr>
-          <p:cNvPr id="6" name="PlaceHolder 2"/>
+          <p:cNvPr id="8" name="PlaceHolder 2"/>
           <p:cNvSpPr>
             <a:spLocks noGrp="1"/>
           </p:cNvSpPr>
@@ -89,7 +257,7 @@
         <p:spPr>
           <a:xfrm>
             <a:off x="504000" y="1326600"/>
-            <a:ext cx="9071640" cy="3288240"/>
+            <a:ext cx="9072000" cy="3288600"/>
           </a:xfrm>
           <a:prstGeom prst="rect">
             <a:avLst/>
@@ -123,7 +291,7 @@
             <a:spLocks noGrp="1"/>
           </p:cNvSpPr>
           <p:nvPr>
-            <p:ph type="ftr" idx="2"/>
+            <p:ph type="ftr" idx="1"/>
           </p:nvPr>
         </p:nvSpPr>
         <p:spPr/>
@@ -143,14 +311,14 @@
             <a:spLocks noGrp="1"/>
           </p:cNvSpPr>
           <p:nvPr>
-            <p:ph type="sldNum" idx="3"/>
+            <p:ph type="sldNum" idx="2"/>
           </p:nvPr>
         </p:nvSpPr>
         <p:spPr/>
         <p:txBody>
           <a:bodyPr/>
           <a:p>
-            <a:fld id="{5035F802-B269-470A-A8FF-858D1FA55B1D}" type="slidenum">
+            <a:fld id="{B3484024-6718-4D6D-9D19-584E35F51642}" type="slidenum">
               <a:t>&lt;#&gt;</a:t>
             </a:fld>
           </a:p>
@@ -163,7 +331,7 @@
             <a:spLocks noGrp="1"/>
           </p:cNvSpPr>
           <p:nvPr>
-            <p:ph type="dt" idx="1"/>
+            <p:ph type="dt" idx="3"/>
           </p:nvPr>
         </p:nvSpPr>
         <p:spPr/>
@@ -212,7 +380,7 @@
         <p:spPr>
           <a:xfrm>
             <a:off x="504000" y="226080"/>
-            <a:ext cx="9071640" cy="946440"/>
+            <a:ext cx="9071280" cy="946080"/>
           </a:xfrm>
           <a:prstGeom prst="rect">
             <a:avLst/>
@@ -227,11 +395,11 @@
             <a:noAutofit/>
           </a:bodyPr>
           <a:p>
-            <a:pPr indent="0" algn="ctr">
+            <a:pPr indent="0">
               <a:buNone/>
             </a:pPr>
             <a:r>
-              <a:rPr b="0" lang="en-US" sz="4400" spc="-1" strike="noStrike">
+              <a:rPr b="0" lang="en-US" sz="1800" spc="-1" strike="noStrike">
                 <a:solidFill>
                   <a:srgbClr val="000000"/>
                 </a:solidFill>
@@ -239,7 +407,7 @@
               </a:rPr>
               <a:t>Click to edit the title text format</a:t>
             </a:r>
-            <a:endParaRPr b="0" lang="en-US" sz="4400" spc="-1" strike="noStrike">
+            <a:endParaRPr b="0" lang="en-US" sz="1800" spc="-1" strike="noStrike">
               <a:solidFill>
                 <a:srgbClr val="000000"/>
               </a:solidFill>
@@ -255,13 +423,13 @@
             <a:spLocks noGrp="1"/>
           </p:cNvSpPr>
           <p:nvPr>
-            <p:ph type="body"/>
+            <p:ph type="ftr" idx="1"/>
           </p:nvPr>
         </p:nvSpPr>
         <p:spPr>
           <a:xfrm>
-            <a:off x="504000" y="1326600"/>
-            <a:ext cx="9071640" cy="3288240"/>
+            <a:off x="3447360" y="5165280"/>
+            <a:ext cx="3194640" cy="390240"/>
           </a:xfrm>
           <a:prstGeom prst="rect">
             <a:avLst/>
@@ -273,202 +441,49 @@
         </p:spPr>
         <p:txBody>
           <a:bodyPr lIns="0" rIns="0" tIns="0" bIns="0" anchor="t">
-            <a:normAutofit/>
+            <a:noAutofit/>
           </a:bodyPr>
-          <a:p>
-            <a:pPr marL="432000" indent="-324000">
-              <a:spcBef>
-                <a:spcPts val="1417"/>
-              </a:spcBef>
-              <a:buClr>
-                <a:srgbClr val="000000"/>
-              </a:buClr>
-              <a:buSzPct val="45000"/>
-              <a:buFont typeface="Wingdings" charset="2"/>
-              <a:buChar char=""/>
+          <a:lstStyle>
+            <a:lvl1pPr indent="0" algn="ctr">
+              <a:lnSpc>
+                <a:spcPct val="100000"/>
+              </a:lnSpc>
+              <a:buNone/>
+              <a:tabLst>
+                <a:tab algn="l" pos="0"/>
+              </a:tabLst>
+              <a:defRPr b="0" lang="en-US" sz="1400" spc="-1" strike="noStrike">
+                <a:solidFill>
+                  <a:srgbClr val="000000"/>
+                </a:solidFill>
+                <a:latin typeface="Times New Roman"/>
+              </a:defRPr>
+            </a:lvl1pPr>
+          </a:lstStyle>
+          <a:p>
+            <a:pPr indent="0" algn="ctr">
+              <a:lnSpc>
+                <a:spcPct val="100000"/>
+              </a:lnSpc>
+              <a:buNone/>
+              <a:tabLst>
+                <a:tab algn="l" pos="0"/>
+              </a:tabLst>
             </a:pPr>
             <a:r>
-              <a:rPr b="0" lang="en-US" sz="3200" spc="-1" strike="noStrike">
-                <a:solidFill>
-                  <a:srgbClr val="000000"/>
-                </a:solidFill>
-                <a:latin typeface="Arial"/>
+              <a:rPr b="0" lang="en-US" sz="1400" spc="-1" strike="noStrike">
+                <a:solidFill>
+                  <a:srgbClr val="000000"/>
+                </a:solidFill>
+                <a:latin typeface="Times New Roman"/>
               </a:rPr>
-              <a:t>Click to edit the outline text format</a:t>
-            </a:r>
-            <a:endParaRPr b="0" lang="en-US" sz="3200" spc="-1" strike="noStrike">
-              <a:solidFill>
-                <a:srgbClr val="000000"/>
-              </a:solidFill>
-              <a:latin typeface="Arial"/>
-            </a:endParaRPr>
-          </a:p>
-          <a:p>
-            <a:pPr lvl="1" marL="864000" indent="-324000">
-              <a:spcBef>
-                <a:spcPts val="1134"/>
-              </a:spcBef>
-              <a:buClr>
-                <a:srgbClr val="000000"/>
-              </a:buClr>
-              <a:buSzPct val="75000"/>
-              <a:buFont typeface="Symbol" charset="2"/>
-              <a:buChar char=""/>
-            </a:pPr>
-            <a:r>
-              <a:rPr b="0" lang="en-US" sz="2800" spc="-1" strike="noStrike">
-                <a:solidFill>
-                  <a:srgbClr val="000000"/>
-                </a:solidFill>
-                <a:latin typeface="Arial"/>
-              </a:rPr>
-              <a:t>Second Outline Level</a:t>
-            </a:r>
-            <a:endParaRPr b="0" lang="en-US" sz="2800" spc="-1" strike="noStrike">
-              <a:solidFill>
-                <a:srgbClr val="000000"/>
-              </a:solidFill>
-              <a:latin typeface="Arial"/>
-            </a:endParaRPr>
-          </a:p>
-          <a:p>
-            <a:pPr lvl="2" marL="1296000" indent="-288000">
-              <a:spcBef>
-                <a:spcPts val="850"/>
-              </a:spcBef>
-              <a:buClr>
-                <a:srgbClr val="000000"/>
-              </a:buClr>
-              <a:buSzPct val="45000"/>
-              <a:buFont typeface="Wingdings" charset="2"/>
-              <a:buChar char=""/>
-            </a:pPr>
-            <a:r>
-              <a:rPr b="0" lang="en-US" sz="2400" spc="-1" strike="noStrike">
-                <a:solidFill>
-                  <a:srgbClr val="000000"/>
-                </a:solidFill>
-                <a:latin typeface="Arial"/>
-              </a:rPr>
-              <a:t>Third Outline Level</a:t>
-            </a:r>
-            <a:endParaRPr b="0" lang="en-US" sz="2400" spc="-1" strike="noStrike">
-              <a:solidFill>
-                <a:srgbClr val="000000"/>
-              </a:solidFill>
-              <a:latin typeface="Arial"/>
-            </a:endParaRPr>
-          </a:p>
-          <a:p>
-            <a:pPr lvl="3" marL="1728000" indent="-216000">
-              <a:spcBef>
-                <a:spcPts val="567"/>
-              </a:spcBef>
-              <a:buClr>
-                <a:srgbClr val="000000"/>
-              </a:buClr>
-              <a:buSzPct val="75000"/>
-              <a:buFont typeface="Symbol" charset="2"/>
-              <a:buChar char=""/>
-            </a:pPr>
-            <a:r>
-              <a:rPr b="0" lang="en-US" sz="2000" spc="-1" strike="noStrike">
-                <a:solidFill>
-                  <a:srgbClr val="000000"/>
-                </a:solidFill>
-                <a:latin typeface="Arial"/>
-              </a:rPr>
-              <a:t>Fourth Outline Level</a:t>
-            </a:r>
-            <a:endParaRPr b="0" lang="en-US" sz="2000" spc="-1" strike="noStrike">
-              <a:solidFill>
-                <a:srgbClr val="000000"/>
-              </a:solidFill>
-              <a:latin typeface="Arial"/>
-            </a:endParaRPr>
-          </a:p>
-          <a:p>
-            <a:pPr lvl="4" marL="2160000" indent="-216000">
-              <a:spcBef>
-                <a:spcPts val="283"/>
-              </a:spcBef>
-              <a:buClr>
-                <a:srgbClr val="000000"/>
-              </a:buClr>
-              <a:buSzPct val="45000"/>
-              <a:buFont typeface="Wingdings" charset="2"/>
-              <a:buChar char=""/>
-            </a:pPr>
-            <a:r>
-              <a:rPr b="0" lang="en-US" sz="2000" spc="-1" strike="noStrike">
-                <a:solidFill>
-                  <a:srgbClr val="000000"/>
-                </a:solidFill>
-                <a:latin typeface="Arial"/>
-              </a:rPr>
-              <a:t>Fifth Outline Level</a:t>
-            </a:r>
-            <a:endParaRPr b="0" lang="en-US" sz="2000" spc="-1" strike="noStrike">
-              <a:solidFill>
-                <a:srgbClr val="000000"/>
-              </a:solidFill>
-              <a:latin typeface="Arial"/>
-            </a:endParaRPr>
-          </a:p>
-          <a:p>
-            <a:pPr lvl="5" marL="2592000" indent="-216000">
-              <a:spcBef>
-                <a:spcPts val="283"/>
-              </a:spcBef>
-              <a:buClr>
-                <a:srgbClr val="000000"/>
-              </a:buClr>
-              <a:buSzPct val="45000"/>
-              <a:buFont typeface="Wingdings" charset="2"/>
-              <a:buChar char=""/>
-            </a:pPr>
-            <a:r>
-              <a:rPr b="0" lang="en-US" sz="2000" spc="-1" strike="noStrike">
-                <a:solidFill>
-                  <a:srgbClr val="000000"/>
-                </a:solidFill>
-                <a:latin typeface="Arial"/>
-              </a:rPr>
-              <a:t>Sixth Outline Level</a:t>
-            </a:r>
-            <a:endParaRPr b="0" lang="en-US" sz="2000" spc="-1" strike="noStrike">
-              <a:solidFill>
-                <a:srgbClr val="000000"/>
-              </a:solidFill>
-              <a:latin typeface="Arial"/>
-            </a:endParaRPr>
-          </a:p>
-          <a:p>
-            <a:pPr lvl="6" marL="3024000" indent="-216000">
-              <a:spcBef>
-                <a:spcPts val="283"/>
-              </a:spcBef>
-              <a:buClr>
-                <a:srgbClr val="000000"/>
-              </a:buClr>
-              <a:buSzPct val="45000"/>
-              <a:buFont typeface="Wingdings" charset="2"/>
-              <a:buChar char=""/>
-            </a:pPr>
-            <a:r>
-              <a:rPr b="0" lang="en-US" sz="2000" spc="-1" strike="noStrike">
-                <a:solidFill>
-                  <a:srgbClr val="000000"/>
-                </a:solidFill>
-                <a:latin typeface="Arial"/>
-              </a:rPr>
-              <a:t>Seventh Outline Level</a:t>
-            </a:r>
-            <a:endParaRPr b="0" lang="en-US" sz="2000" spc="-1" strike="noStrike">
-              <a:solidFill>
-                <a:srgbClr val="000000"/>
-              </a:solidFill>
-              <a:latin typeface="Arial"/>
+              <a:t>&lt;footer&gt;</a:t>
+            </a:r>
+            <a:endParaRPr b="0" lang="en-US" sz="1400" spc="-1" strike="noStrike">
+              <a:solidFill>
+                <a:srgbClr val="000000"/>
+              </a:solidFill>
+              <a:latin typeface="Times New Roman"/>
             </a:endParaRPr>
           </a:p>
         </p:txBody>
@@ -480,13 +495,85 @@
             <a:spLocks noGrp="1"/>
           </p:cNvSpPr>
           <p:nvPr>
-            <p:ph type="dt" idx="1"/>
+            <p:ph type="sldNum" idx="2"/>
           </p:nvPr>
         </p:nvSpPr>
         <p:spPr>
           <a:xfrm>
+            <a:off x="7227360" y="5165280"/>
+            <a:ext cx="2347920" cy="390240"/>
+          </a:xfrm>
+          <a:prstGeom prst="rect">
+            <a:avLst/>
+          </a:prstGeom>
+          <a:noFill/>
+          <a:ln w="0">
+            <a:noFill/>
+          </a:ln>
+        </p:spPr>
+        <p:txBody>
+          <a:bodyPr lIns="0" rIns="0" tIns="0" bIns="0" anchor="t">
+            <a:noAutofit/>
+          </a:bodyPr>
+          <a:lstStyle>
+            <a:lvl1pPr indent="0" algn="r">
+              <a:lnSpc>
+                <a:spcPct val="100000"/>
+              </a:lnSpc>
+              <a:buNone/>
+              <a:tabLst>
+                <a:tab algn="l" pos="0"/>
+              </a:tabLst>
+              <a:defRPr b="0" lang="en-US" sz="1400" spc="-1" strike="noStrike">
+                <a:solidFill>
+                  <a:srgbClr val="000000"/>
+                </a:solidFill>
+                <a:latin typeface="Times New Roman"/>
+              </a:defRPr>
+            </a:lvl1pPr>
+          </a:lstStyle>
+          <a:p>
+            <a:pPr indent="0" algn="r">
+              <a:lnSpc>
+                <a:spcPct val="100000"/>
+              </a:lnSpc>
+              <a:buNone/>
+              <a:tabLst>
+                <a:tab algn="l" pos="0"/>
+              </a:tabLst>
+            </a:pPr>
+            <a:fld id="{9F77B614-372E-4676-A281-9FAFDB60F8D2}" type="slidenum">
+              <a:rPr b="0" lang="en-US" sz="1400" spc="-1" strike="noStrike">
+                <a:solidFill>
+                  <a:srgbClr val="000000"/>
+                </a:solidFill>
+                <a:latin typeface="Times New Roman"/>
+              </a:rPr>
+              <a:t>&lt;number&gt;</a:t>
+            </a:fld>
+            <a:endParaRPr b="0" lang="en-US" sz="1400" spc="-1" strike="noStrike">
+              <a:solidFill>
+                <a:srgbClr val="000000"/>
+              </a:solidFill>
+              <a:latin typeface="Times New Roman"/>
+            </a:endParaRPr>
+          </a:p>
+        </p:txBody>
+      </p:sp>
+      <p:sp>
+        <p:nvSpPr>
+          <p:cNvPr id="3" name="PlaceHolder 4"/>
+          <p:cNvSpPr>
+            <a:spLocks noGrp="1"/>
+          </p:cNvSpPr>
+          <p:nvPr>
+            <p:ph type="dt" idx="3"/>
+          </p:nvPr>
+        </p:nvSpPr>
+        <p:spPr>
+          <a:xfrm>
             <a:off x="504000" y="5165280"/>
-            <a:ext cx="2348280" cy="390600"/>
+            <a:ext cx="2347920" cy="390240"/>
           </a:xfrm>
           <a:prstGeom prst="rect">
             <a:avLst/>
@@ -535,78 +622,18 @@
       </p:sp>
       <p:sp>
         <p:nvSpPr>
-          <p:cNvPr id="3" name="PlaceHolder 4"/>
-          <p:cNvSpPr>
-            <a:spLocks noGrp="1"/>
-          </p:cNvSpPr>
-          <p:nvPr>
-            <p:ph type="ftr" idx="2"/>
-          </p:nvPr>
-        </p:nvSpPr>
-        <p:spPr>
-          <a:xfrm>
-            <a:off x="3447360" y="5165280"/>
-            <a:ext cx="3195000" cy="390600"/>
-          </a:xfrm>
-          <a:prstGeom prst="rect">
-            <a:avLst/>
-          </a:prstGeom>
-          <a:noFill/>
-          <a:ln w="0">
-            <a:noFill/>
-          </a:ln>
-        </p:spPr>
-        <p:txBody>
-          <a:bodyPr lIns="0" rIns="0" tIns="0" bIns="0" anchor="t">
-            <a:noAutofit/>
-          </a:bodyPr>
-          <a:lstStyle>
-            <a:lvl1pPr indent="0" algn="ctr">
-              <a:buNone/>
-              <a:defRPr b="0" lang="en-US" sz="1400" spc="-1" strike="noStrike">
-                <a:solidFill>
-                  <a:srgbClr val="000000"/>
-                </a:solidFill>
-                <a:latin typeface="Times New Roman"/>
-              </a:defRPr>
-            </a:lvl1pPr>
-          </a:lstStyle>
-          <a:p>
-            <a:pPr indent="0" algn="ctr">
-              <a:buNone/>
-            </a:pPr>
-            <a:r>
-              <a:rPr b="0" lang="en-US" sz="1400" spc="-1" strike="noStrike">
-                <a:solidFill>
-                  <a:srgbClr val="000000"/>
-                </a:solidFill>
-                <a:latin typeface="Times New Roman"/>
-              </a:rPr>
-              <a:t>&lt;footer&gt;</a:t>
-            </a:r>
-            <a:endParaRPr b="0" lang="en-US" sz="1400" spc="-1" strike="noStrike">
-              <a:solidFill>
-                <a:srgbClr val="000000"/>
-              </a:solidFill>
-              <a:latin typeface="Times New Roman"/>
-            </a:endParaRPr>
-          </a:p>
-        </p:txBody>
-      </p:sp>
-      <p:sp>
-        <p:nvSpPr>
           <p:cNvPr id="4" name="PlaceHolder 5"/>
           <p:cNvSpPr>
             <a:spLocks noGrp="1"/>
           </p:cNvSpPr>
           <p:nvPr>
-            <p:ph type="sldNum" idx="3"/>
+            <p:ph type="body"/>
           </p:nvPr>
         </p:nvSpPr>
         <p:spPr>
           <a:xfrm>
-            <a:off x="7227360" y="5165280"/>
-            <a:ext cx="2348280" cy="390600"/>
+            <a:off x="504000" y="1326600"/>
+            <a:ext cx="9072000" cy="3288600"/>
           </a:xfrm>
           <a:prstGeom prst="rect">
             <a:avLst/>
@@ -618,37 +645,202 @@
         </p:spPr>
         <p:txBody>
           <a:bodyPr lIns="0" rIns="0" tIns="0" bIns="0" anchor="t">
-            <a:noAutofit/>
+            <a:normAutofit/>
           </a:bodyPr>
-          <a:lstStyle>
-            <a:lvl1pPr indent="0" algn="r">
-              <a:buNone/>
-              <a:defRPr b="0" lang="en-US" sz="1400" spc="-1" strike="noStrike">
-                <a:solidFill>
-                  <a:srgbClr val="000000"/>
-                </a:solidFill>
-                <a:latin typeface="Times New Roman"/>
-              </a:defRPr>
-            </a:lvl1pPr>
-          </a:lstStyle>
-          <a:p>
-            <a:pPr indent="0" algn="r">
-              <a:buNone/>
+          <a:p>
+            <a:pPr marL="432000" indent="-324000">
+              <a:spcBef>
+                <a:spcPts val="1417"/>
+              </a:spcBef>
+              <a:buClr>
+                <a:srgbClr val="000000"/>
+              </a:buClr>
+              <a:buSzPct val="45000"/>
+              <a:buFont typeface="Wingdings" charset="2"/>
+              <a:buChar char=""/>
             </a:pPr>
-            <a:fld id="{8B8EE69C-6EAA-401C-8006-A5FCA5366B2D}" type="slidenum">
-              <a:rPr b="0" lang="en-US" sz="1400" spc="-1" strike="noStrike">
-                <a:solidFill>
-                  <a:srgbClr val="000000"/>
-                </a:solidFill>
-                <a:latin typeface="Times New Roman"/>
+            <a:r>
+              <a:rPr b="0" lang="en-US" sz="3200" spc="-1" strike="noStrike">
+                <a:solidFill>
+                  <a:srgbClr val="000000"/>
+                </a:solidFill>
+                <a:latin typeface="Arial"/>
               </a:rPr>
-              <a:t>&lt;number&gt;</a:t>
-            </a:fld>
-            <a:endParaRPr b="0" lang="en-US" sz="1400" spc="-1" strike="noStrike">
-              <a:solidFill>
-                <a:srgbClr val="000000"/>
-              </a:solidFill>
-              <a:latin typeface="Times New Roman"/>
+              <a:t>Click to edit the outline text format</a:t>
+            </a:r>
+            <a:endParaRPr b="0" lang="en-US" sz="3200" spc="-1" strike="noStrike">
+              <a:solidFill>
+                <a:srgbClr val="000000"/>
+              </a:solidFill>
+              <a:latin typeface="Arial"/>
+            </a:endParaRPr>
+          </a:p>
+          <a:p>
+            <a:pPr lvl="1" marL="864000" indent="-324000">
+              <a:spcBef>
+                <a:spcPts val="1134"/>
+              </a:spcBef>
+              <a:buClr>
+                <a:srgbClr val="000000"/>
+              </a:buClr>
+              <a:buSzPct val="75000"/>
+              <a:buFont typeface="Symbol" charset="2"/>
+              <a:buChar char=""/>
+            </a:pPr>
+            <a:r>
+              <a:rPr b="0" lang="en-US" sz="2800" spc="-1" strike="noStrike">
+                <a:solidFill>
+                  <a:srgbClr val="000000"/>
+                </a:solidFill>
+                <a:latin typeface="Arial"/>
+              </a:rPr>
+              <a:t>Second Outline Level</a:t>
+            </a:r>
+            <a:endParaRPr b="0" lang="en-US" sz="2800" spc="-1" strike="noStrike">
+              <a:solidFill>
+                <a:srgbClr val="000000"/>
+              </a:solidFill>
+              <a:latin typeface="Arial"/>
+            </a:endParaRPr>
+          </a:p>
+          <a:p>
+            <a:pPr lvl="2" marL="1296000" indent="-288000">
+              <a:spcBef>
+                <a:spcPts val="850"/>
+              </a:spcBef>
+              <a:buClr>
+                <a:srgbClr val="000000"/>
+              </a:buClr>
+              <a:buSzPct val="45000"/>
+              <a:buFont typeface="Wingdings" charset="2"/>
+              <a:buChar char=""/>
+            </a:pPr>
+            <a:r>
+              <a:rPr b="0" lang="en-US" sz="2400" spc="-1" strike="noStrike">
+                <a:solidFill>
+                  <a:srgbClr val="000000"/>
+                </a:solidFill>
+                <a:latin typeface="Arial"/>
+              </a:rPr>
+              <a:t>Third Outline Level</a:t>
+            </a:r>
+            <a:endParaRPr b="0" lang="en-US" sz="2400" spc="-1" strike="noStrike">
+              <a:solidFill>
+                <a:srgbClr val="000000"/>
+              </a:solidFill>
+              <a:latin typeface="Arial"/>
+            </a:endParaRPr>
+          </a:p>
+          <a:p>
+            <a:pPr lvl="3" marL="1728000" indent="-216000">
+              <a:spcBef>
+                <a:spcPts val="567"/>
+              </a:spcBef>
+              <a:buClr>
+                <a:srgbClr val="000000"/>
+              </a:buClr>
+              <a:buSzPct val="75000"/>
+              <a:buFont typeface="Symbol" charset="2"/>
+              <a:buChar char=""/>
+            </a:pPr>
+            <a:r>
+              <a:rPr b="0" lang="en-US" sz="2000" spc="-1" strike="noStrike">
+                <a:solidFill>
+                  <a:srgbClr val="000000"/>
+                </a:solidFill>
+                <a:latin typeface="Arial"/>
+              </a:rPr>
+              <a:t>Fourth Outline Level</a:t>
+            </a:r>
+            <a:endParaRPr b="0" lang="en-US" sz="2000" spc="-1" strike="noStrike">
+              <a:solidFill>
+                <a:srgbClr val="000000"/>
+              </a:solidFill>
+              <a:latin typeface="Arial"/>
+            </a:endParaRPr>
+          </a:p>
+          <a:p>
+            <a:pPr lvl="4" marL="2160000" indent="-216000">
+              <a:spcBef>
+                <a:spcPts val="283"/>
+              </a:spcBef>
+              <a:buClr>
+                <a:srgbClr val="000000"/>
+              </a:buClr>
+              <a:buSzPct val="45000"/>
+              <a:buFont typeface="Wingdings" charset="2"/>
+              <a:buChar char=""/>
+            </a:pPr>
+            <a:r>
+              <a:rPr b="0" lang="en-US" sz="2000" spc="-1" strike="noStrike">
+                <a:solidFill>
+                  <a:srgbClr val="000000"/>
+                </a:solidFill>
+                <a:latin typeface="Arial"/>
+              </a:rPr>
+              <a:t>Fifth Outline Level</a:t>
+            </a:r>
+            <a:endParaRPr b="0" lang="en-US" sz="2000" spc="-1" strike="noStrike">
+              <a:solidFill>
+                <a:srgbClr val="000000"/>
+              </a:solidFill>
+              <a:latin typeface="Arial"/>
+            </a:endParaRPr>
+          </a:p>
+          <a:p>
+            <a:pPr lvl="5" marL="2592000" indent="-216000">
+              <a:spcBef>
+                <a:spcPts val="283"/>
+              </a:spcBef>
+              <a:buClr>
+                <a:srgbClr val="000000"/>
+              </a:buClr>
+              <a:buSzPct val="45000"/>
+              <a:buFont typeface="Wingdings" charset="2"/>
+              <a:buChar char=""/>
+            </a:pPr>
+            <a:r>
+              <a:rPr b="0" lang="en-US" sz="2000" spc="-1" strike="noStrike">
+                <a:solidFill>
+                  <a:srgbClr val="000000"/>
+                </a:solidFill>
+                <a:latin typeface="Arial"/>
+              </a:rPr>
+              <a:t>Sixth Outline Level</a:t>
+            </a:r>
+            <a:endParaRPr b="0" lang="en-US" sz="2000" spc="-1" strike="noStrike">
+              <a:solidFill>
+                <a:srgbClr val="000000"/>
+              </a:solidFill>
+              <a:latin typeface="Arial"/>
+            </a:endParaRPr>
+          </a:p>
+          <a:p>
+            <a:pPr lvl="6" marL="3024000" indent="-216000">
+              <a:spcBef>
+                <a:spcPts val="283"/>
+              </a:spcBef>
+              <a:buClr>
+                <a:srgbClr val="000000"/>
+              </a:buClr>
+              <a:buSzPct val="45000"/>
+              <a:buFont typeface="Wingdings" charset="2"/>
+              <a:buChar char=""/>
+            </a:pPr>
+            <a:r>
+              <a:rPr b="0" lang="en-US" sz="2000" spc="-1" strike="noStrike">
+                <a:solidFill>
+                  <a:srgbClr val="000000"/>
+                </a:solidFill>
+                <a:latin typeface="Arial"/>
+              </a:rPr>
+              <a:t>Seventh Outline Level</a:t>
+            </a:r>
+            <a:endParaRPr b="0" lang="en-US" sz="2000" spc="-1" strike="noStrike">
+              <a:solidFill>
+                <a:srgbClr val="000000"/>
+              </a:solidFill>
+              <a:latin typeface="Arial"/>
             </a:endParaRPr>
           </a:p>
         </p:txBody>
@@ -658,6 +850,7 @@
   <p:clrMap bg1="lt1" bg2="lt2" tx1="dk1" tx2="dk2" accent1="accent1" accent2="accent2" accent3="accent3" accent4="accent4" accent5="accent5" accent6="accent6" hlink="hlink" folHlink="folHlink"/>
   <p:sldLayoutIdLst>
     <p:sldLayoutId id="2147483649" r:id="rId2"/>
+    <p:sldLayoutId id="2147483650" r:id="rId3"/>
   </p:sldLayoutIdLst>
 </p:sldMaster>
 </file>
@@ -681,7 +874,7 @@
       </p:grpSpPr>
       <p:pic>
         <p:nvPicPr>
-          <p:cNvPr id="7" name="" descr=""/>
+          <p:cNvPr id="9" name="" descr=""/>
           <p:cNvPicPr/>
           <p:nvPr/>
         </p:nvPicPr>
@@ -691,8 +884,8 @@
         </p:blipFill>
         <p:spPr>
           <a:xfrm>
-            <a:off x="15480" y="9360"/>
-            <a:ext cx="10079640" cy="5669640"/>
+            <a:off x="18360" y="9360"/>
+            <a:ext cx="10073520" cy="5668920"/>
           </a:xfrm>
           <a:prstGeom prst="rect">
             <a:avLst/>
@@ -702,6 +895,160 @@
           </a:ln>
         </p:spPr>
       </p:pic>
+      <p:sp>
+        <p:nvSpPr>
+          <p:cNvPr id="10" name=""/>
+          <p:cNvSpPr/>
+          <p:nvPr/>
+        </p:nvSpPr>
+        <p:spPr>
+          <a:xfrm>
+            <a:off x="1143000" y="613800"/>
+            <a:ext cx="6628680" cy="985680"/>
+          </a:xfrm>
+          <a:prstGeom prst="rect">
+            <a:avLst/>
+          </a:prstGeom>
+          <a:solidFill>
+            <a:srgbClr val="ffffff"/>
+          </a:solidFill>
+          <a:ln w="0">
+            <a:solidFill>
+              <a:srgbClr val="ffffff"/>
+            </a:solidFill>
+          </a:ln>
+        </p:spPr>
+        <p:style>
+          <a:lnRef idx="0"/>
+          <a:fillRef idx="0"/>
+          <a:effectRef idx="0"/>
+          <a:fontRef idx="minor"/>
+        </p:style>
+        <p:txBody>
+          <a:bodyPr lIns="90000" rIns="90000" tIns="45000" bIns="45000" anchor="ctr">
+            <a:noAutofit/>
+          </a:bodyPr>
+          <a:p>
+            <a:endParaRPr b="0" lang="en-US" sz="1800" spc="-1" strike="noStrike">
+              <a:solidFill>
+                <a:srgbClr val="000000"/>
+              </a:solidFill>
+              <a:latin typeface="Arial"/>
+              <a:ea typeface="DejaVu Sans"/>
+            </a:endParaRPr>
+          </a:p>
+        </p:txBody>
+      </p:sp>
+      <p:sp>
+        <p:nvSpPr>
+          <p:cNvPr id="11" name=""/>
+          <p:cNvSpPr/>
+          <p:nvPr/>
+        </p:nvSpPr>
+        <p:spPr>
+          <a:xfrm>
+            <a:off x="1180800" y="421200"/>
+            <a:ext cx="8822520" cy="884880"/>
+          </a:xfrm>
+          <a:prstGeom prst="rect">
+            <a:avLst/>
+          </a:prstGeom>
+          <a:noFill/>
+          <a:ln w="0">
+            <a:noFill/>
+          </a:ln>
+        </p:spPr>
+        <p:style>
+          <a:lnRef idx="0"/>
+          <a:fillRef idx="0"/>
+          <a:effectRef idx="0"/>
+          <a:fontRef idx="minor"/>
+        </p:style>
+        <p:txBody>
+          <a:bodyPr wrap="none" lIns="90000" rIns="90000" tIns="45000" bIns="45000" anchor="t">
+            <a:noAutofit/>
+          </a:bodyPr>
+          <a:p>
+            <a:pPr algn="ctr">
+              <a:lnSpc>
+                <a:spcPct val="100000"/>
+              </a:lnSpc>
+            </a:pPr>
+            <a:r>
+              <a:rPr b="1" lang="en-US" sz="2000" spc="-1" strike="noStrike">
+                <a:solidFill>
+                  <a:srgbClr val="2a6099"/>
+                </a:solidFill>
+                <a:latin typeface="Arial"/>
+                <a:ea typeface="DejaVu Sans"/>
+              </a:rPr>
+              <a:t>Population differentiation via Fst and F-statistics</a:t>
+            </a:r>
+            <a:br>
+              <a:rPr sz="2000"/>
+            </a:br>
+            <a:r>
+              <a:rPr b="0" lang="en-US" sz="1800" spc="-1" strike="noStrike">
+                <a:solidFill>
+                  <a:srgbClr val="000000"/>
+                </a:solidFill>
+                <a:latin typeface="Arial"/>
+                <a:ea typeface="DejaVu Sans"/>
+              </a:rPr>
+              <a:t>PR Stats Course</a:t>
+            </a:r>
+            <a:br>
+              <a:rPr sz="1800"/>
+            </a:br>
+            <a:r>
+              <a:rPr b="0" lang="en-US" sz="1800" spc="-1" strike="noStrike">
+                <a:solidFill>
+                  <a:srgbClr val="000000"/>
+                </a:solidFill>
+                <a:latin typeface="Arial"/>
+                <a:ea typeface="DejaVu Sans"/>
+              </a:rPr>
+              <a:t>Nikolay Oskolkov, Group Leader (PI) at NIRI, Riga, Latvia</a:t>
+            </a:r>
+            <a:endParaRPr b="0" lang="en-US" sz="1800" spc="-1" strike="noStrike">
+              <a:solidFill>
+                <a:srgbClr val="000000"/>
+              </a:solidFill>
+              <a:latin typeface="Arial"/>
+            </a:endParaRPr>
+          </a:p>
+        </p:txBody>
+      </p:sp>
+    </p:spTree>
+  </p:cSld>
+  <mc:AlternateContent>
+    <mc:Choice Requires="p14">
+      <p:transition spd="slow" p14:dur="2000"/>
+    </mc:Choice>
+    <mc:Fallback>
+      <p:transition spd="slow"/>
+    </mc:Fallback>
+  </mc:AlternateContent>
+</p:sld>
+</file>
+
+<file path=ppt/slides/slide10.xml><?xml version="1.0" encoding="utf-8"?>
+<p:sld xmlns:a="http://schemas.openxmlformats.org/drawingml/2006/main" xmlns:p="http://schemas.openxmlformats.org/presentationml/2006/main" xmlns:r="http://schemas.openxmlformats.org/officeDocument/2006/relationships" xmlns:p14="http://schemas.microsoft.com/office/powerpoint/2010/main" xmlns:p15="http://schemas.microsoft.com/office/powerpoint/2012/main" xmlns:mc="http://schemas.openxmlformats.org/markup-compatibility/2006">
+  <p:cSld>
+    <p:spTree>
+      <p:nvGrpSpPr>
+        <p:cNvPr id="1" name=""/>
+        <p:cNvGrpSpPr/>
+        <p:nvPr/>
+      </p:nvGrpSpPr>
+      <p:grpSpPr>
+        <a:xfrm>
+          <a:off x="0" y="0"/>
+          <a:ext cx="0" cy="0"/>
+          <a:chOff x="0" y="0"/>
+          <a:chExt cx="0" cy="0"/>
+        </a:xfrm>
+      </p:grpSpPr>
     </p:spTree>
   </p:cSld>
   <mc:AlternateContent>
@@ -734,7 +1081,7 @@
       </p:grpSpPr>
       <p:pic>
         <p:nvPicPr>
-          <p:cNvPr id="8" name="" descr=""/>
+          <p:cNvPr id="12" name="" descr=""/>
           <p:cNvPicPr/>
           <p:nvPr/>
         </p:nvPicPr>
@@ -744,8 +1091,8 @@
         </p:blipFill>
         <p:spPr>
           <a:xfrm>
-            <a:off x="15480" y="9360"/>
-            <a:ext cx="10079640" cy="5669640"/>
+            <a:off x="2286000" y="1600200"/>
+            <a:ext cx="5465880" cy="2290320"/>
           </a:xfrm>
           <a:prstGeom prst="rect">
             <a:avLst/>
@@ -755,6 +1102,90 @@
           </a:ln>
         </p:spPr>
       </p:pic>
+      <p:sp>
+        <p:nvSpPr>
+          <p:cNvPr id="13" name=""/>
+          <p:cNvSpPr txBox="1"/>
+          <p:nvPr/>
+        </p:nvSpPr>
+        <p:spPr>
+          <a:xfrm>
+            <a:off x="371160" y="4788000"/>
+            <a:ext cx="9312480" cy="346320"/>
+          </a:xfrm>
+          <a:prstGeom prst="rect">
+            <a:avLst/>
+          </a:prstGeom>
+          <a:noFill/>
+          <a:ln w="0">
+            <a:noFill/>
+          </a:ln>
+        </p:spPr>
+        <p:txBody>
+          <a:bodyPr wrap="none" lIns="90000" rIns="90000" tIns="45000" bIns="45000" anchor="t">
+            <a:noAutofit/>
+          </a:bodyPr>
+          <a:p>
+            <a:r>
+              <a:rPr b="0" lang="en-US" sz="1800" spc="-1" strike="noStrike">
+                <a:solidFill>
+                  <a:srgbClr val="000000"/>
+                </a:solidFill>
+                <a:latin typeface="Arial"/>
+              </a:rPr>
+              <a:t>Importantly, one should not mix up individual heterozygosity and population heterozygosity</a:t>
+            </a:r>
+            <a:endParaRPr b="0" lang="en-US" sz="1800" spc="-1" strike="noStrike">
+              <a:solidFill>
+                <a:srgbClr val="000000"/>
+              </a:solidFill>
+              <a:latin typeface="Arial"/>
+            </a:endParaRPr>
+          </a:p>
+        </p:txBody>
+      </p:sp>
+      <p:sp>
+        <p:nvSpPr>
+          <p:cNvPr id="14" name=""/>
+          <p:cNvSpPr txBox="1"/>
+          <p:nvPr/>
+        </p:nvSpPr>
+        <p:spPr>
+          <a:xfrm>
+            <a:off x="1852200" y="228600"/>
+            <a:ext cx="6427440" cy="459360"/>
+          </a:xfrm>
+          <a:prstGeom prst="rect">
+            <a:avLst/>
+          </a:prstGeom>
+          <a:noFill/>
+          <a:ln w="0">
+            <a:noFill/>
+          </a:ln>
+        </p:spPr>
+        <p:txBody>
+          <a:bodyPr wrap="none" lIns="90000" rIns="90000" tIns="45000" bIns="45000" anchor="t">
+            <a:noAutofit/>
+          </a:bodyPr>
+          <a:p>
+            <a:r>
+              <a:rPr b="1" lang="en-US" sz="2600" spc="-1" strike="noStrike">
+                <a:solidFill>
+                  <a:srgbClr val="000000"/>
+                </a:solidFill>
+                <a:latin typeface="Arial"/>
+              </a:rPr>
+              <a:t>Nucleotide diversity and heterozygosity</a:t>
+            </a:r>
+            <a:endParaRPr b="0" lang="en-US" sz="2600" spc="-1" strike="noStrike">
+              <a:solidFill>
+                <a:srgbClr val="000000"/>
+              </a:solidFill>
+              <a:latin typeface="Arial"/>
+            </a:endParaRPr>
+          </a:p>
+        </p:txBody>
+      </p:sp>
     </p:spTree>
   </p:cSld>
   <mc:AlternateContent>
@@ -787,7 +1218,7 @@
       </p:grpSpPr>
       <p:pic>
         <p:nvPicPr>
-          <p:cNvPr id="9" name="" descr=""/>
+          <p:cNvPr id="15" name="" descr=""/>
           <p:cNvPicPr/>
           <p:nvPr/>
         </p:nvPicPr>
@@ -798,7 +1229,7 @@
         <p:spPr>
           <a:xfrm>
             <a:off x="15480" y="9360"/>
-            <a:ext cx="10079640" cy="5669640"/>
+            <a:ext cx="10079280" cy="5669280"/>
           </a:xfrm>
           <a:prstGeom prst="rect">
             <a:avLst/>
@@ -840,7 +1271,7 @@
       </p:grpSpPr>
       <p:pic>
         <p:nvPicPr>
-          <p:cNvPr id="10" name="" descr=""/>
+          <p:cNvPr id="16" name="" descr=""/>
           <p:cNvPicPr/>
           <p:nvPr/>
         </p:nvPicPr>
@@ -851,7 +1282,7 @@
         <p:spPr>
           <a:xfrm>
             <a:off x="15480" y="9360"/>
-            <a:ext cx="10079640" cy="5669640"/>
+            <a:ext cx="10079280" cy="5669280"/>
           </a:xfrm>
           <a:prstGeom prst="rect">
             <a:avLst/>
@@ -893,7 +1324,7 @@
       </p:grpSpPr>
       <p:pic>
         <p:nvPicPr>
-          <p:cNvPr id="11" name="" descr=""/>
+          <p:cNvPr id="17" name="" descr=""/>
           <p:cNvPicPr/>
           <p:nvPr/>
         </p:nvPicPr>
@@ -904,7 +1335,7 @@
         <p:spPr>
           <a:xfrm>
             <a:off x="15480" y="9360"/>
-            <a:ext cx="10079640" cy="5669640"/>
+            <a:ext cx="10079280" cy="5669280"/>
           </a:xfrm>
           <a:prstGeom prst="rect">
             <a:avLst/>
@@ -946,7 +1377,7 @@
       </p:grpSpPr>
       <p:pic>
         <p:nvPicPr>
-          <p:cNvPr id="12" name="" descr=""/>
+          <p:cNvPr id="18" name="" descr=""/>
           <p:cNvPicPr/>
           <p:nvPr/>
         </p:nvPicPr>
@@ -957,7 +1388,7 @@
         <p:spPr>
           <a:xfrm>
             <a:off x="15480" y="9360"/>
-            <a:ext cx="10079640" cy="5669640"/>
+            <a:ext cx="10079280" cy="5669280"/>
           </a:xfrm>
           <a:prstGeom prst="rect">
             <a:avLst/>
@@ -999,7 +1430,7 @@
       </p:grpSpPr>
       <p:pic>
         <p:nvPicPr>
-          <p:cNvPr id="13" name="" descr=""/>
+          <p:cNvPr id="19" name="" descr=""/>
           <p:cNvPicPr/>
           <p:nvPr/>
         </p:nvPicPr>
@@ -1010,7 +1441,7 @@
         <p:spPr>
           <a:xfrm>
             <a:off x="15480" y="9360"/>
-            <a:ext cx="10079640" cy="5669640"/>
+            <a:ext cx="10079280" cy="5669280"/>
           </a:xfrm>
           <a:prstGeom prst="rect">
             <a:avLst/>
@@ -1050,6 +1481,82 @@
           <a:chExt cx="0" cy="0"/>
         </a:xfrm>
       </p:grpSpPr>
+      <p:pic>
+        <p:nvPicPr>
+          <p:cNvPr id="20" name="" descr=""/>
+          <p:cNvPicPr/>
+          <p:nvPr/>
+        </p:nvPicPr>
+        <p:blipFill>
+          <a:blip r:embed="rId1"/>
+          <a:stretch/>
+        </p:blipFill>
+        <p:spPr>
+          <a:xfrm>
+            <a:off x="15480" y="9360"/>
+            <a:ext cx="10079280" cy="5669280"/>
+          </a:xfrm>
+          <a:prstGeom prst="rect">
+            <a:avLst/>
+          </a:prstGeom>
+          <a:ln w="0">
+            <a:noFill/>
+          </a:ln>
+        </p:spPr>
+      </p:pic>
+    </p:spTree>
+  </p:cSld>
+  <mc:AlternateContent>
+    <mc:Choice Requires="p14">
+      <p:transition spd="slow" p14:dur="2000"/>
+    </mc:Choice>
+    <mc:Fallback>
+      <p:transition spd="slow"/>
+    </mc:Fallback>
+  </mc:AlternateContent>
+</p:sld>
+</file>
+
+<file path=ppt/slides/slide9.xml><?xml version="1.0" encoding="utf-8"?>
+<p:sld xmlns:a="http://schemas.openxmlformats.org/drawingml/2006/main" xmlns:p="http://schemas.openxmlformats.org/presentationml/2006/main" xmlns:r="http://schemas.openxmlformats.org/officeDocument/2006/relationships" xmlns:p14="http://schemas.microsoft.com/office/powerpoint/2010/main" xmlns:p15="http://schemas.microsoft.com/office/powerpoint/2012/main" xmlns:mc="http://schemas.openxmlformats.org/markup-compatibility/2006">
+  <p:cSld>
+    <p:spTree>
+      <p:nvGrpSpPr>
+        <p:cNvPr id="1" name=""/>
+        <p:cNvGrpSpPr/>
+        <p:nvPr/>
+      </p:nvGrpSpPr>
+      <p:grpSpPr>
+        <a:xfrm>
+          <a:off x="0" y="0"/>
+          <a:ext cx="0" cy="0"/>
+          <a:chOff x="0" y="0"/>
+          <a:chExt cx="0" cy="0"/>
+        </a:xfrm>
+      </p:grpSpPr>
+      <p:pic>
+        <p:nvPicPr>
+          <p:cNvPr id="21" name="" descr=""/>
+          <p:cNvPicPr/>
+          <p:nvPr/>
+        </p:nvPicPr>
+        <p:blipFill>
+          <a:blip r:embed="rId1"/>
+          <a:stretch/>
+        </p:blipFill>
+        <p:spPr>
+          <a:xfrm>
+            <a:off x="15480" y="9360"/>
+            <a:ext cx="10079280" cy="5669280"/>
+          </a:xfrm>
+          <a:prstGeom prst="rect">
+            <a:avLst/>
+          </a:prstGeom>
+          <a:ln w="0">
+            <a:noFill/>
+          </a:ln>
+        </p:spPr>
+      </p:pic>
     </p:spTree>
   </p:cSld>
   <mc:AlternateContent>

</xml_diff>